<commit_message>
docs: add comprehensive project documentation report and visual architecture graphs
</commit_message>
<xml_diff>
--- a/reports/presentation/greenlens_presentation.pptx
+++ b/reports/presentation/greenlens_presentation.pptx
@@ -3201,8 +3201,8 @@
         </p:nvSpPr>
         <p:spPr>
           <a:xfrm>
-            <a:off x="822960" y="4389120"/>
-            <a:ext cx="5486400" cy="1737360"/>
+            <a:off x="822960" y="4206240"/>
+            <a:ext cx="5486400" cy="2057400"/>
           </a:xfrm>
           <a:prstGeom prst="roundRect">
             <a:avLst/>
@@ -3246,8 +3246,8 @@
         </p:nvSpPr>
         <p:spPr>
           <a:xfrm>
-            <a:off x="1005840" y="4480560"/>
-            <a:ext cx="5120640" cy="1554480"/>
+            <a:off x="1005840" y="4297680"/>
+            <a:ext cx="5120640" cy="1874519"/>
           </a:xfrm>
           <a:prstGeom prst="rect">
             <a:avLst/>
@@ -3262,9 +3262,9 @@
           <a:p>
             <a:pPr>
               <a:spcAft>
-                <a:spcPts val="600"/>
-              </a:spcAft>
-              <a:defRPr sz="1300" b="1">
+                <a:spcPts val="400"/>
+              </a:spcAft>
+              <a:defRPr sz="1250" b="1">
                 <a:solidFill>
                   <a:srgbClr val="1B4332"/>
                 </a:solidFill>
@@ -3277,9 +3277,9 @@
           <a:p>
             <a:pPr>
               <a:spcAft>
-                <a:spcPts val="600"/>
-              </a:spcAft>
-              <a:defRPr sz="1200" b="1">
+                <a:spcPts val="400"/>
+              </a:spcAft>
+              <a:defRPr sz="1150" b="1">
                 <a:solidFill>
                   <a:srgbClr val="2D6A4F"/>
                 </a:solidFill>
@@ -3294,7 +3294,7 @@
               <a:spcAft>
                 <a:spcPts val="400"/>
               </a:spcAft>
-              <a:defRPr sz="1200">
+              <a:defRPr sz="1150">
                 <a:solidFill>
                   <a:srgbClr val="2D3748"/>
                 </a:solidFill>
@@ -3306,6 +3306,9 @@
           </a:p>
           <a:p>
             <a:pPr>
+              <a:spcAft>
+                <a:spcPts val="500"/>
+              </a:spcAft>
               <a:defRPr sz="1100">
                 <a:solidFill>
                   <a:srgbClr val="64748B"/>
@@ -3314,6 +3317,25 @@
             </a:pPr>
             <a:r>
               <a:t>Course:  Introduction to Algorithms (Year 3, Semester 1)</a:t>
+            </a:r>
+          </a:p>
+          <a:p>
+            <a:r>
+              <a:rPr sz="1050" b="1">
+                <a:solidFill>
+                  <a:srgbClr val="2D3748"/>
+                </a:solidFill>
+              </a:rPr>
+              <a:t>Repository:  </a:t>
+            </a:r>
+            <a:r>
+              <a:rPr sz="1000" b="1">
+                <a:solidFill>
+                  <a:srgbClr val="2D6A4F"/>
+                </a:solidFill>
+                <a:hlinkClick r:id="rId2"/>
+              </a:rPr>
+              <a:t>https://github.com/AbdelazizElbanna/greenlens</a:t>
             </a:r>
           </a:p>
         </p:txBody>
@@ -3327,7 +3349,7 @@
           <p:nvPr/>
         </p:nvPicPr>
         <p:blipFill>
-          <a:blip r:embed="rId2"/>
+          <a:blip r:embed="rId3"/>
           <a:stretch>
             <a:fillRect/>
           </a:stretch>

</xml_diff>